<commit_message>
Tune thresholds and add GitHub handoff guide
</commit_message>
<xml_diff>
--- a/slides/volcano_eruption_prediction_review.pptx
+++ b/slides/volcano_eruption_prediction_review.pptx
@@ -4685,7 +4685,7 @@
                 </a:solidFill>
                 <a:latin typeface="Aptos"/>
               </a:rPr>
-              <a:t>0.478</a:t>
+              <a:t>0.475</a:t>
             </a:r>
           </a:p>
         </p:txBody>
@@ -4720,7 +4720,7 @@
                 </a:solidFill>
                 <a:latin typeface="Aptos"/>
               </a:rPr>
-              <a:t>0.096</a:t>
+              <a:t>0.086</a:t>
             </a:r>
           </a:p>
         </p:txBody>
@@ -4755,7 +4755,7 @@
                 </a:solidFill>
                 <a:latin typeface="Aptos"/>
               </a:rPr>
-              <a:t>0.046</a:t>
+              <a:t>0.041</a:t>
             </a:r>
           </a:p>
         </p:txBody>
@@ -4860,7 +4860,7 @@
                 </a:solidFill>
                 <a:latin typeface="Aptos"/>
               </a:rPr>
-              <a:t>0.549</a:t>
+              <a:t>0.636</a:t>
             </a:r>
           </a:p>
         </p:txBody>
@@ -4895,7 +4895,7 @@
                 </a:solidFill>
                 <a:latin typeface="Aptos"/>
               </a:rPr>
-              <a:t>0.709</a:t>
+              <a:t>0.541</a:t>
             </a:r>
           </a:p>
         </p:txBody>
@@ -4930,7 +4930,7 @@
                 </a:solidFill>
                 <a:latin typeface="Aptos"/>
               </a:rPr>
-              <a:t>-0.002</a:t>
+              <a:t>0.308</a:t>
             </a:r>
           </a:p>
         </p:txBody>
@@ -5000,7 +5000,7 @@
                 </a:solidFill>
                 <a:latin typeface="Aptos"/>
               </a:rPr>
-              <a:t>Random Forest: ROC-AUC 0.822</a:t>
+              <a:t>Random Forest: ROC-AUC 0.822, tuned threshold 0.75, kappa 0.308</a:t>
             </a:r>
             <a:br/>
             <a:r>
@@ -5020,7 +5020,7 @@
                 </a:solidFill>
                 <a:latin typeface="Aptos"/>
               </a:rPr>
-              <a:t>A ranking metric is more informative here than accuracy alone because the event rate shifts over time.</a:t>
+              <a:t>Thresholds were selected on development data before the held-out test.</a:t>
             </a:r>
           </a:p>
         </p:txBody>
@@ -5194,7 +5194,7 @@
                 </a:solidFill>
                 <a:latin typeface="Aptos"/>
               </a:rPr>
-              <a:t>The Random Forest captures nonlinear structure but defaults to an overly aggressive positive class.</a:t>
+              <a:t>Development-set threshold tuning makes the Random Forest more balanced on the held-out period.</a:t>
             </a:r>
             <a:br/>
             <a:r>
@@ -5204,7 +5204,7 @@
                 </a:solidFill>
                 <a:latin typeface="Aptos"/>
               </a:rPr>
-              <a:t>Near-zero kappa at the default threshold warns against treating raw predictions as alerts.</a:t>
+              <a:t>The experiment remains retrospective and should not be treated as an operational alert system.</a:t>
             </a:r>
           </a:p>
         </p:txBody>

</xml_diff>

<commit_message>
Add team members and section details
</commit_message>
<xml_diff>
--- a/slides/volcano_eruption_prediction_review.pptx
+++ b/slides/volcano_eruption_prediction_review.pptx
@@ -3155,7 +3155,7 @@
         </p:nvSpPr>
         <p:spPr>
           <a:xfrm>
-            <a:off x="640080" y="3154680"/>
+            <a:off x="640080" y="3063240"/>
             <a:ext cx="10789920" cy="411480"/>
           </a:xfrm>
           <a:prstGeom prst="rect">
@@ -3177,7 +3177,7 @@
                 </a:solidFill>
                 <a:latin typeface="Aptos"/>
               </a:rPr>
-              <a:t>UE24CS352A Machine Learning Mini-Project</a:t>
+              <a:t>UE24CS352A Machine Learning Mini-Project - Section E</a:t>
             </a:r>
           </a:p>
         </p:txBody>
@@ -3185,6 +3185,41 @@
       <p:sp>
         <p:nvSpPr>
           <p:cNvPr id="4" name="TextBox 3"/>
+          <p:cNvSpPr txBox="1"/>
+          <p:nvPr/>
+        </p:nvSpPr>
+        <p:spPr>
+          <a:xfrm>
+            <a:off x="640080" y="3493008"/>
+            <a:ext cx="10789920" cy="320040"/>
+          </a:xfrm>
+          <a:prstGeom prst="rect">
+            <a:avLst/>
+          </a:prstGeom>
+          <a:noFill/>
+        </p:spPr>
+        <p:txBody>
+          <a:bodyPr wrap="square">
+            <a:spAutoFit/>
+          </a:bodyPr>
+          <a:lstStyle/>
+          <a:p>
+            <a:pPr algn="ctr"/>
+            <a:r>
+              <a:rPr sz="1500" b="0">
+                <a:solidFill>
+                  <a:srgbClr val="E2E9EF"/>
+                </a:solidFill>
+                <a:latin typeface="Aptos"/>
+              </a:rPr>
+              <a:t>Muhammad Uzair  |  Mokshithreddy Nallaballe</a:t>
+            </a:r>
+          </a:p>
+        </p:txBody>
+      </p:sp>
+      <p:sp>
+        <p:nvSpPr>
+          <p:cNvPr id="5" name="TextBox 4"/>
           <p:cNvSpPr txBox="1"/>
           <p:nvPr/>
         </p:nvSpPr>

</xml_diff>

<commit_message>
Add GitHub repository link to deliverables
</commit_message>
<xml_diff>
--- a/slides/volcano_eruption_prediction_review.pptx
+++ b/slides/volcano_eruption_prediction_review.pptx
@@ -5490,6 +5490,41 @@
                 <a:latin typeface="Aptos"/>
               </a:rPr>
               <a:t>Add waveform, tremor, GPS, and gas-emission features</a:t>
+            </a:r>
+          </a:p>
+        </p:txBody>
+      </p:sp>
+      <p:sp>
+        <p:nvSpPr>
+          <p:cNvPr id="8" name="TextBox 7"/>
+          <p:cNvSpPr txBox="1"/>
+          <p:nvPr/>
+        </p:nvSpPr>
+        <p:spPr>
+          <a:xfrm>
+            <a:off x="822960" y="5715000"/>
+            <a:ext cx="10058400" cy="320040"/>
+          </a:xfrm>
+          <a:prstGeom prst="rect">
+            <a:avLst/>
+          </a:prstGeom>
+          <a:noFill/>
+        </p:spPr>
+        <p:txBody>
+          <a:bodyPr wrap="square">
+            <a:spAutoFit/>
+          </a:bodyPr>
+          <a:lstStyle/>
+          <a:p>
+            <a:pPr algn="ctr"/>
+            <a:r>
+              <a:rPr sz="1400" b="0">
+                <a:solidFill>
+                  <a:srgbClr val="DD6C27"/>
+                </a:solidFill>
+                <a:latin typeface="Aptos"/>
+              </a:rPr>
+              <a:t>Repository: github.com/mokshithr530/volcano-eruption-ml</a:t>
             </a:r>
           </a:p>
         </p:txBody>

</xml_diff>